<commit_message>
refactor: scope claims to hypothetical, add public-safety disclaimer
</commit_message>
<xml_diff>
--- a/assets/samon_care_robot_deck.pptx
+++ b/assets/samon_care_robot_deck.pptx
@@ -1570,7 +1570,7 @@
                 <a:ea typeface="Malgun Gothic" pitchFamily="34" charset="-122"/>
                 <a:cs typeface="Malgun Gothic" pitchFamily="34" charset="-120"/>
               </a:rPr>
-              <a:t>LG CLOi for Home Care — 낮에는 인지중재, 밤에는 다약제(polypharmacy) 안전 모니터링.</a:t>
+              <a:t>CLOi-class 서비스 로봇 가정 돌봄 시나리오 — 낮에는 인지중재, 밤에는 다약제(polypharmacy) 안전 모니터링.</a:t>
             </a:r>
             <a:endParaRPr lang="en-US" sz="1900" dirty="0"/>
           </a:p>
@@ -1609,7 +1609,7 @@
                 <a:ea typeface="Malgun Gothic" pitchFamily="34" charset="-122"/>
                 <a:cs typeface="Malgun Gothic" pitchFamily="34" charset="-120"/>
               </a:rPr>
-              <a:t>ROSA 5-Layer × LG CLOi 플랫폼 × Upstage Solar LLM × 통합돌봄법(2026.3)</a:t>
+              <a:t>ROSA 5-Layer × CLOi-class platform × Upstage Solar LLM × 통합돌봄법(2026.3) — 개념 탐구</a:t>
             </a:r>
             <a:endParaRPr lang="en-US" sz="1200" dirty="0"/>
           </a:p>
@@ -5213,7 +5213,7 @@
                 <a:ea typeface="Malgun Gothic" pitchFamily="34" charset="-122"/>
                 <a:cs typeface="Malgun Gothic" pitchFamily="34" charset="-120"/>
               </a:rPr>
-              <a:t>LG CLOi가 비어 있는 가정 돌봄 카테고리를 연다.</a:t>
+              <a:t>CLOi-class 서비스 로봇이 열 수 있는 가정 돌봄 카테고리.</a:t>
             </a:r>
             <a:endParaRPr lang="en-US" sz="2800" dirty="0"/>
           </a:p>
@@ -6377,7 +6377,7 @@
                 <a:ea typeface="Malgun Gothic" pitchFamily="34" charset="-122"/>
                 <a:cs typeface="Malgun Gothic" pitchFamily="34" charset="-120"/>
               </a:rPr>
-              <a:t>삼온 (LG CLOi 기반)</a:t>
+              <a:t>삼온 (CLOi-class 적용)</a:t>
             </a:r>
             <a:endParaRPr lang="en-US" sz="1200" dirty="0"/>
           </a:p>
@@ -6572,7 +6572,7 @@
                 <a:ea typeface="Malgun Gothic" pitchFamily="34" charset="-122"/>
                 <a:cs typeface="Malgun Gothic" pitchFamily="34" charset="-120"/>
               </a:rPr>
-              <a:t>LG CLOi의 검증된 자율주행·HRI 위에, 본 팀이 가정 돌봄 SW 계층을 얹는다.</a:t>
+              <a:t>CLOi-class 서비스 로봇의 자율주행·HRI 위에 가정 돌봄 SW 계층을 얹는 개념 탐구.</a:t>
             </a:r>
             <a:endParaRPr lang="en-US" sz="1100" dirty="0"/>
           </a:p>
@@ -8652,7 +8652,7 @@
                 <a:ea typeface="Malgun Gothic" pitchFamily="34" charset="-122"/>
                 <a:cs typeface="Malgun Gothic" pitchFamily="34" charset="-120"/>
               </a:rPr>
-              <a:t>LG CLOi + Upstage Solar 통합 PoC</a:t>
+              <a:t>CLOi-class platform + Upstage Solar 통합 PoC</a:t>
             </a:r>
             <a:endParaRPr lang="en-US" sz="1100" dirty="0"/>
           </a:p>
@@ -8922,7 +8922,7 @@
                 <a:ea typeface="Malgun Gothic" pitchFamily="34" charset="-122"/>
                 <a:cs typeface="Malgun Gothic" pitchFamily="34" charset="-120"/>
               </a:rPr>
-              <a:t>LG CLOi for Home Care 베타</a:t>
+              <a:t>CLOi-class Home Care 베타</a:t>
             </a:r>
             <a:endParaRPr lang="en-US" sz="1700" dirty="0"/>
           </a:p>
@@ -9009,7 +9009,7 @@
                 <a:ea typeface="Malgun Gothic" pitchFamily="34" charset="-122"/>
                 <a:cs typeface="Malgun Gothic" pitchFamily="34" charset="-120"/>
               </a:rPr>
-              <a:t>LG 사내 검증 + 50가구 파일럿</a:t>
+              <a:t>하드웨어 파트너 사내 검증 + 50가구 파일럿 (가설)</a:t>
             </a:r>
             <a:endParaRPr lang="en-US" sz="1100" dirty="0"/>
           </a:p>
@@ -9343,7 +9343,7 @@
                 <a:ea typeface="Malgun Gothic" pitchFamily="34" charset="-122"/>
                 <a:cs typeface="Malgun Gothic" pitchFamily="34" charset="-120"/>
               </a:rPr>
-              <a:t>양산 + LG 글로벌 출시</a:t>
+              <a:t>양산 + 글로벌 출시 (가설)</a:t>
             </a:r>
             <a:endParaRPr lang="en-US" sz="1700" dirty="0"/>
           </a:p>
@@ -9558,7 +9558,7 @@
                 <a:ea typeface="Malgun Gothic" pitchFamily="34" charset="-122"/>
                 <a:cs typeface="Malgun Gothic" pitchFamily="34" charset="-120"/>
               </a:rPr>
-              <a:t>LG 일본·동남아·중동 수출</a:t>
+              <a:t>글로벌 가전 채널 수출 (가설)</a:t>
             </a:r>
             <a:endParaRPr lang="en-US" sz="1100" dirty="0"/>
           </a:p>

</xml_diff>